<commit_message>
Update report and decks with Sentinel-1 and Thatako basin analysis
- Detailed report: new chapter 12 (Thatako AOI/domain, scenarios A-E,
  Sentinel-1 2017-2025 flood history, 2021/2022/2025 event reconstruction
  vs S1, tambon tables, remaining mismatches); satellite calibration targets
  in ch.10; exec summary, limitations, recommendations, references, history
- Executive deck: +3 slides (S1 history, scenario mechanism, event results)
- Technical deck: +6 slides (S1 method, Thatako domain/scenarios, S1 vs
  model, event setup/parameters, per-year results, per-tambon + mismatches)
- Client deck: +1 proof slide; limitations/next steps/date updated

Co-Authored-By: Claude Opus 5.5 <noreply@anthropic.com>
Claude-Session: https://claude.ai/code/session_01Fa6PZV7131nRSshrS984GL
</commit_message>
<xml_diff>
--- a/docs/report/NakhonSawanFlood_ลูกค้าและหน่วยงานราชการ.pptx
+++ b/docs/report/NakhonSawanFlood_ลูกค้าและหน่วยงานราชการ.pptx
@@ -11,6 +11,7 @@
     <p:sldId id="259" r:id="rId5"/>
     <p:sldId id="260" r:id="rId6"/>
     <p:sldId id="261" r:id="rId7"/>
+    <p:sldId id="268" r:id="rId19"/>
     <p:sldId id="262" r:id="rId8"/>
     <p:sldId id="263" r:id="rId9"/>
     <p:sldId id="264" r:id="rId10"/>
@@ -3945,6 +3946,10 @@
             <a:prstDash val="solid"/>
           </a:ln>
         </p:spPr>
+        <p:txBody>
+          <a:bodyPr/>
+          <a:p/>
+        </p:txBody>
       </p:sp>
       <p:sp>
         <p:nvSpPr>
@@ -3970,6 +3975,10 @@
             <a:prstDash val="solid"/>
           </a:ln>
         </p:spPr>
+        <p:txBody>
+          <a:bodyPr/>
+          <a:p/>
+        </p:txBody>
       </p:sp>
       <p:sp>
         <p:nvSpPr>
@@ -4120,6 +4129,10 @@
             <a:prstDash val="solid"/>
           </a:ln>
         </p:spPr>
+        <p:txBody>
+          <a:bodyPr/>
+          <a:p/>
+        </p:txBody>
       </p:sp>
       <p:sp>
         <p:nvSpPr>
@@ -4145,6 +4158,10 @@
             <a:prstDash val="solid"/>
           </a:ln>
         </p:spPr>
+        <p:txBody>
+          <a:bodyPr/>
+          <a:p/>
+        </p:txBody>
       </p:sp>
       <p:sp>
         <p:nvSpPr>
@@ -4218,7 +4235,7 @@
                 <a:ea typeface="Prompt" pitchFamily="34" charset="-122"/>
                 <a:cs typeface="Prompt" pitchFamily="34" charset="-120"/>
               </a:rPr>
-              <a:t>ต้องยืนยันกับข้อมูลจริง</a:t>
+              <a:t>ยืนยันกับข้อมูลจริงต่อเนื่อง</a:t>
             </a:r>
             <a:endParaRPr lang="en-US" sz="1600" dirty="0"/>
           </a:p>
@@ -4263,7 +4280,7 @@
                 <a:ea typeface="Prompt" pitchFamily="34" charset="-122"/>
                 <a:cs typeface="Prompt" pitchFamily="34" charset="-120"/>
               </a:rPr>
-              <a:t>ยังไม่ได้เทียบกับภาพดาวเทียม GISTDA และรายงานภาคสนาม</a:t>
+              <a:t>แอ่งท่าตะโกเทียบดาวเทียมแล้ว (CSI ~0.5) · พื้นที่อื่นสะสมภาพต่อ และควรมีรายงานภาคสนาม</a:t>
             </a:r>
             <a:endParaRPr lang="en-US" sz="1450" dirty="0"/>
           </a:p>
@@ -5153,6 +5170,10 @@
             <a:prstDash val="solid"/>
           </a:ln>
         </p:spPr>
+        <p:txBody>
+          <a:bodyPr/>
+          <a:p/>
+        </p:txBody>
       </p:sp>
       <p:sp>
         <p:nvSpPr>
@@ -5178,6 +5199,10 @@
             <a:prstDash val="solid"/>
           </a:ln>
         </p:spPr>
+        <p:txBody>
+          <a:bodyPr/>
+          <a:p/>
+        </p:txBody>
       </p:sp>
       <p:sp>
         <p:nvSpPr>
@@ -5293,7 +5318,7 @@
                 <a:ea typeface="Prompt" pitchFamily="34" charset="-122"/>
                 <a:cs typeface="Prompt" pitchFamily="34" charset="-120"/>
               </a:rPr>
-              <a:t>เทียบผลกับภาพดาวเทียม GISTDA และเหตุการณ์น้ำท่วมในอดีต</a:t>
+              <a:t>ขยายการเทียบดาวเทียมทั้งจังหวัด + ข้อมูลประตูน้ำ/บึงจาก ชป.</a:t>
             </a:r>
             <a:endParaRPr lang="en-US" sz="1650" dirty="0"/>
           </a:p>
@@ -6192,7 +6217,7 @@
                 <a:ea typeface="Prompt" pitchFamily="34" charset="-122"/>
                 <a:cs typeface="Prompt" pitchFamily="34" charset="-120"/>
               </a:rPr>
-              <a:t>ข้อมูล ณ 28 ก.ย. 2569 เวลา 20:57 น. · ตัวเลขทั้งหมดเป็นผลแบบจำลอง</a:t>
+              <a:t>ข้อมูล ณ 28 ก.ย. 2569 เวลา 20:57 น. · ผลแอ่งท่าตะโก 30 ก.ย. 2569 · ตัวเลขทั้งหมดเป็นผลแบบจำลอง</a:t>
             </a:r>
             <a:endParaRPr lang="en-US" sz="1200" dirty="0"/>
           </a:p>
@@ -6255,6 +6280,943 @@
           </a:prstGeom>
         </p:spPr>
       </p:pic>
+    </p:spTree>
+  </p:cSld>
+  <p:clrMapOvr>
+    <a:masterClrMapping/>
+  </p:clrMapOvr>
+</p:sld>
+</file>
+
+<file path=ppt/slides/slide13.xml><?xml version="1.0" encoding="utf-8"?>
+<p:sld xmlns:a="http://schemas.openxmlformats.org/drawingml/2006/main" xmlns:p="http://schemas.openxmlformats.org/presentationml/2006/main" xmlns:r="http://schemas.openxmlformats.org/officeDocument/2006/relationships">
+  <p:cSld>
+    <p:bg>
+      <p:bgPr>
+        <a:solidFill>
+          <a:srgbClr val="FFFFFF"/>
+        </a:solidFill>
+      </p:bgPr>
+    </p:bg>
+    <p:spTree>
+      <p:nvGrpSpPr>
+        <p:cNvPr id="1" name=""/>
+        <p:cNvGrpSpPr/>
+        <p:nvPr/>
+      </p:nvGrpSpPr>
+      <p:grpSpPr/>
+      <p:sp>
+        <p:nvSpPr>
+          <p:cNvPr id="25" name="Slide Number Placeholder 0"/>
+          <p:cNvSpPr>
+            <a:spLocks noGrp="1"/>
+          </p:cNvSpPr>
+          <p:nvPr>
+            <p:ph type="sldNum" sz="quarter" idx="4294967295"/>
+          </p:nvPr>
+        </p:nvSpPr>
+        <p:spPr>
+          <a:xfrm>
+            <a:off x="11277295" y="6419088"/>
+            <a:ext cx="457200" cy="274320"/>
+          </a:xfrm>
+          <a:prstGeom prst="rect">
+            <a:avLst/>
+          </a:prstGeom>
+          <a:extLst>
+            <a:ext uri="{C572A759-6A51-4108-AA02-DFA0A04FC94B}">
+              <ma14:wrappingTextBoxFlag xmlns:ma14="http://schemas.microsoft.com/office/mac/drawingml/2011/main" val="0"/>
+            </a:ext>
+          </a:extLst>
+        </p:spPr>
+        <p:txBody>
+          <a:bodyPr/>
+          <a:lstStyle>
+            <a:lvl1pPr>
+              <a:defRPr sz="900">
+                <a:solidFill>
+                  <a:srgbClr val="64748B"/>
+                </a:solidFill>
+                <a:latin typeface="Prompt"/>
+                <a:ea typeface="Prompt"/>
+                <a:cs typeface="Prompt"/>
+              </a:defRPr>
+            </a:lvl1pPr>
+          </a:lstStyle>
+          <a:p>
+            <a:pPr algn="r"/>
+            <a:fld id="{F7021451-1387-4CA6-816F-3879F97B5CBC}" type="slidenum">
+              <a:rPr b="0" lang="en-US"/>
+              <a:t>2</a:t>
+            </a:fld>
+            <a:endParaRPr lang="en-US"/>
+          </a:p>
+        </p:txBody>
+      </p:sp>
+      <p:sp>
+        <p:nvSpPr>
+          <p:cNvPr id="26" name="TextBox 25"/>
+          <p:cNvSpPr txBox="1"/>
+          <p:nvPr/>
+        </p:nvSpPr>
+        <p:spPr>
+          <a:xfrm>
+            <a:off x="548640" y="347472"/>
+            <a:ext cx="8229600" cy="274320"/>
+          </a:xfrm>
+          <a:prstGeom prst="rect">
+            <a:avLst/>
+          </a:prstGeom>
+          <a:noFill/>
+        </p:spPr>
+        <p:txBody>
+          <a:bodyPr wrap="square" lIns="0" rIns="0" tIns="0" bIns="0" anchor="t">
+            <a:spAutoFit/>
+          </a:bodyPr>
+          <a:lstStyle/>
+          <a:p>
+            <a:pPr algn="l"/>
+            <a:r>
+              <a:rPr sz="1200" b="1" i="0">
+                <a:solidFill>
+                  <a:srgbClr val="1B998B"/>
+                </a:solidFill>
+                <a:latin typeface="Prompt"/>
+                <a:ea typeface="Prompt"/>
+                <a:cs typeface="Prompt"/>
+              </a:rPr>
+              <a:t>พิสูจน์กับน้ำท่วมจริง</a:t>
+            </a:r>
+          </a:p>
+        </p:txBody>
+      </p:sp>
+      <p:sp>
+        <p:nvSpPr>
+          <p:cNvPr id="27" name="TextBox 26"/>
+          <p:cNvSpPr txBox="1"/>
+          <p:nvPr/>
+        </p:nvSpPr>
+        <p:spPr>
+          <a:xfrm>
+            <a:off x="548640" y="621792"/>
+            <a:ext cx="11091672" cy="685800"/>
+          </a:xfrm>
+          <a:prstGeom prst="rect">
+            <a:avLst/>
+          </a:prstGeom>
+          <a:noFill/>
+        </p:spPr>
+        <p:txBody>
+          <a:bodyPr wrap="square" lIns="0" rIns="0" tIns="0" bIns="0" anchor="ctr">
+            <a:spAutoFit/>
+          </a:bodyPr>
+          <a:lstStyle/>
+          <a:p>
+            <a:pPr algn="l"/>
+            <a:r>
+              <a:rPr sz="2600" b="1" i="0">
+                <a:solidFill>
+                  <a:srgbClr val="0B3C5D"/>
+                </a:solidFill>
+                <a:latin typeface="Prompt"/>
+                <a:ea typeface="Prompt"/>
+                <a:cs typeface="Prompt"/>
+              </a:rPr>
+              <a:t>ตัวอย่างแอ่งท่าตะโก: แบบจำลองตรงกับภาพดาวเทียมย้อนหลัง</a:t>
+            </a:r>
+          </a:p>
+        </p:txBody>
+      </p:sp>
+      <p:sp>
+        <p:nvSpPr>
+          <p:cNvPr id="28" name="Rounded Rectangle 27"/>
+          <p:cNvSpPr/>
+          <p:nvPr/>
+        </p:nvSpPr>
+        <p:spPr>
+          <a:xfrm>
+            <a:off x="493776" y="1426464"/>
+            <a:ext cx="4956048" cy="4352544"/>
+          </a:xfrm>
+          <a:prstGeom prst="roundRect">
+            <a:avLst>
+              <a:gd name="adj" fmla="val 1600"/>
+            </a:avLst>
+          </a:prstGeom>
+          <a:solidFill>
+            <a:srgbClr val="FFFFFF"/>
+          </a:solidFill>
+          <a:ln w="9525">
+            <a:solidFill>
+              <a:srgbClr val="D5DEE6"/>
+            </a:solidFill>
+          </a:ln>
+          <a:effectLst/>
+        </p:spPr>
+        <p:style>
+          <a:lnRef idx="1">
+            <a:schemeClr val="accent1"/>
+          </a:lnRef>
+          <a:fillRef idx="3">
+            <a:schemeClr val="accent1"/>
+          </a:fillRef>
+          <a:effectRef idx="2">
+            <a:schemeClr val="accent1"/>
+          </a:effectRef>
+          <a:fontRef idx="minor">
+            <a:schemeClr val="lt1"/>
+          </a:fontRef>
+        </p:style>
+        <p:txBody>
+          <a:bodyPr rtlCol="0" anchor="ctr"/>
+          <a:lstStyle/>
+          <a:p/>
+        </p:txBody>
+      </p:sp>
+      <p:pic>
+        <p:nvPicPr>
+          <p:cNvPr id="29" name="Picture 28" descr="map_ev2025.png"/>
+          <p:cNvPicPr>
+            <a:picLocks noChangeAspect="1"/>
+          </p:cNvPicPr>
+          <p:nvPr/>
+        </p:nvPicPr>
+        <p:blipFill>
+          <a:blip r:embed="rId2"/>
+          <a:stretch>
+            <a:fillRect/>
+          </a:stretch>
+        </p:blipFill>
+        <p:spPr>
+          <a:xfrm>
+            <a:off x="548640" y="1481328"/>
+            <a:ext cx="4846320" cy="4242816"/>
+          </a:xfrm>
+          <a:prstGeom prst="rect">
+            <a:avLst/>
+          </a:prstGeom>
+        </p:spPr>
+      </p:pic>
+      <p:sp>
+        <p:nvSpPr>
+          <p:cNvPr id="30" name="TextBox 29"/>
+          <p:cNvSpPr txBox="1"/>
+          <p:nvPr/>
+        </p:nvSpPr>
+        <p:spPr>
+          <a:xfrm>
+            <a:off x="548640" y="5797296"/>
+            <a:ext cx="4846320" cy="457200"/>
+          </a:xfrm>
+          <a:prstGeom prst="rect">
+            <a:avLst/>
+          </a:prstGeom>
+          <a:noFill/>
+        </p:spPr>
+        <p:txBody>
+          <a:bodyPr wrap="square" lIns="0" rIns="0" tIns="0" bIns="0" anchor="t">
+            <a:spAutoFit/>
+          </a:bodyPr>
+          <a:lstStyle/>
+          <a:p>
+            <a:pPr algn="l"/>
+            <a:r>
+              <a:rPr sz="1050" b="0" i="0">
+                <a:solidFill>
+                  <a:srgbClr val="64748B"/>
+                </a:solidFill>
+                <a:latin typeface="Prompt"/>
+                <a:ea typeface="Prompt"/>
+                <a:cs typeface="Prompt"/>
+              </a:rPr>
+              <a:t>ปี 2568: พื้นที่ท่วมนาน 30 วันขึ้นไป — น้ำเงิน = แบบจำลองกับดาวเทียมตรงกัน</a:t>
+            </a:r>
+          </a:p>
+        </p:txBody>
+      </p:sp>
+      <p:sp>
+        <p:nvSpPr>
+          <p:cNvPr id="31" name="Rounded Rectangle 30"/>
+          <p:cNvSpPr/>
+          <p:nvPr/>
+        </p:nvSpPr>
+        <p:spPr>
+          <a:xfrm>
+            <a:off x="5760720" y="1481328"/>
+            <a:ext cx="1874519" cy="1463040"/>
+          </a:xfrm>
+          <a:prstGeom prst="roundRect">
+            <a:avLst>
+              <a:gd name="adj" fmla="val 6000"/>
+            </a:avLst>
+          </a:prstGeom>
+          <a:solidFill>
+            <a:srgbClr val="EEF5F9"/>
+          </a:solidFill>
+          <a:ln>
+            <a:noFill/>
+          </a:ln>
+          <a:effectLst/>
+        </p:spPr>
+        <p:style>
+          <a:lnRef idx="1">
+            <a:schemeClr val="accent1"/>
+          </a:lnRef>
+          <a:fillRef idx="3">
+            <a:schemeClr val="accent1"/>
+          </a:fillRef>
+          <a:effectRef idx="2">
+            <a:schemeClr val="accent1"/>
+          </a:effectRef>
+          <a:fontRef idx="minor">
+            <a:schemeClr val="lt1"/>
+          </a:fontRef>
+        </p:style>
+        <p:txBody>
+          <a:bodyPr rtlCol="0" anchor="ctr"/>
+          <a:lstStyle/>
+          <a:p/>
+        </p:txBody>
+      </p:sp>
+      <p:sp>
+        <p:nvSpPr>
+          <p:cNvPr id="32" name="TextBox 31"/>
+          <p:cNvSpPr txBox="1"/>
+          <p:nvPr/>
+        </p:nvSpPr>
+        <p:spPr>
+          <a:xfrm>
+            <a:off x="5961888" y="1609344"/>
+            <a:ext cx="1508760" cy="658368"/>
+          </a:xfrm>
+          <a:prstGeom prst="rect">
+            <a:avLst/>
+          </a:prstGeom>
+          <a:noFill/>
+        </p:spPr>
+        <p:txBody>
+          <a:bodyPr wrap="square" lIns="0" rIns="0" tIns="0" bIns="0" anchor="ctr">
+            <a:spAutoFit/>
+          </a:bodyPr>
+          <a:lstStyle/>
+          <a:p>
+            <a:pPr algn="l"/>
+            <a:r>
+              <a:rPr sz="2800" b="1" i="0">
+                <a:solidFill>
+                  <a:srgbClr val="0B3C5D"/>
+                </a:solidFill>
+                <a:latin typeface="Prompt"/>
+                <a:ea typeface="Prompt"/>
+                <a:cs typeface="Prompt"/>
+              </a:rPr>
+              <a:t>9</a:t>
+            </a:r>
+            <a:r>
+              <a:rPr sz="1300" b="0" i="0">
+                <a:solidFill>
+                  <a:srgbClr val="64748B"/>
+                </a:solidFill>
+                <a:latin typeface="Prompt"/>
+                <a:ea typeface="Prompt"/>
+                <a:cs typeface="Prompt"/>
+              </a:rPr>
+              <a:t>  ปี</a:t>
+            </a:r>
+          </a:p>
+        </p:txBody>
+      </p:sp>
+      <p:sp>
+        <p:nvSpPr>
+          <p:cNvPr id="33" name="TextBox 32"/>
+          <p:cNvSpPr txBox="1"/>
+          <p:nvPr/>
+        </p:nvSpPr>
+        <p:spPr>
+          <a:xfrm>
+            <a:off x="5961888" y="2296972"/>
+            <a:ext cx="1508760" cy="658368"/>
+          </a:xfrm>
+          <a:prstGeom prst="rect">
+            <a:avLst/>
+          </a:prstGeom>
+          <a:noFill/>
+        </p:spPr>
+        <p:txBody>
+          <a:bodyPr wrap="square" lIns="0" rIns="0" tIns="0" bIns="0" anchor="t">
+            <a:spAutoFit/>
+          </a:bodyPr>
+          <a:lstStyle/>
+          <a:p>
+            <a:pPr algn="l"/>
+            <a:r>
+              <a:rPr sz="1150" b="0" i="0">
+                <a:solidFill>
+                  <a:srgbClr val="1E293B"/>
+                </a:solidFill>
+                <a:latin typeface="Prompt"/>
+                <a:ea typeface="Prompt"/>
+                <a:cs typeface="Prompt"/>
+              </a:rPr>
+              <a:t>ภาพเรดาร์ย้อนหลัง 148 ภาพ มองทะลุเมฆ</a:t>
+            </a:r>
+          </a:p>
+        </p:txBody>
+      </p:sp>
+      <p:sp>
+        <p:nvSpPr>
+          <p:cNvPr id="34" name="Rounded Rectangle 33"/>
+          <p:cNvSpPr/>
+          <p:nvPr/>
+        </p:nvSpPr>
+        <p:spPr>
+          <a:xfrm>
+            <a:off x="7763256" y="1481328"/>
+            <a:ext cx="1874519" cy="1463040"/>
+          </a:xfrm>
+          <a:prstGeom prst="roundRect">
+            <a:avLst>
+              <a:gd name="adj" fmla="val 6000"/>
+            </a:avLst>
+          </a:prstGeom>
+          <a:solidFill>
+            <a:srgbClr val="EEF5F9"/>
+          </a:solidFill>
+          <a:ln>
+            <a:noFill/>
+          </a:ln>
+          <a:effectLst/>
+        </p:spPr>
+        <p:style>
+          <a:lnRef idx="1">
+            <a:schemeClr val="accent1"/>
+          </a:lnRef>
+          <a:fillRef idx="3">
+            <a:schemeClr val="accent1"/>
+          </a:fillRef>
+          <a:effectRef idx="2">
+            <a:schemeClr val="accent1"/>
+          </a:effectRef>
+          <a:fontRef idx="minor">
+            <a:schemeClr val="lt1"/>
+          </a:fontRef>
+        </p:style>
+        <p:txBody>
+          <a:bodyPr rtlCol="0" anchor="ctr"/>
+          <a:lstStyle/>
+          <a:p/>
+        </p:txBody>
+      </p:sp>
+      <p:sp>
+        <p:nvSpPr>
+          <p:cNvPr id="35" name="TextBox 34"/>
+          <p:cNvSpPr txBox="1"/>
+          <p:nvPr/>
+        </p:nvSpPr>
+        <p:spPr>
+          <a:xfrm>
+            <a:off x="7964424" y="1609344"/>
+            <a:ext cx="1508760" cy="658368"/>
+          </a:xfrm>
+          <a:prstGeom prst="rect">
+            <a:avLst/>
+          </a:prstGeom>
+          <a:noFill/>
+        </p:spPr>
+        <p:txBody>
+          <a:bodyPr wrap="square" lIns="0" rIns="0" tIns="0" bIns="0" anchor="ctr">
+            <a:spAutoFit/>
+          </a:bodyPr>
+          <a:lstStyle/>
+          <a:p>
+            <a:pPr algn="l"/>
+            <a:r>
+              <a:rPr sz="2800" b="1" i="0">
+                <a:solidFill>
+                  <a:srgbClr val="D64545"/>
+                </a:solidFill>
+                <a:latin typeface="Prompt"/>
+                <a:ea typeface="Prompt"/>
+                <a:cs typeface="Prompt"/>
+              </a:rPr>
+              <a:t>2–3</a:t>
+            </a:r>
+            <a:r>
+              <a:rPr sz="1300" b="0" i="0">
+                <a:solidFill>
+                  <a:srgbClr val="64748B"/>
+                </a:solidFill>
+                <a:latin typeface="Prompt"/>
+                <a:ea typeface="Prompt"/>
+                <a:cs typeface="Prompt"/>
+              </a:rPr>
+              <a:t>  เดือน</a:t>
+            </a:r>
+          </a:p>
+        </p:txBody>
+      </p:sp>
+      <p:sp>
+        <p:nvSpPr>
+          <p:cNvPr id="36" name="TextBox 35"/>
+          <p:cNvSpPr txBox="1"/>
+          <p:nvPr/>
+        </p:nvSpPr>
+        <p:spPr>
+          <a:xfrm>
+            <a:off x="7964424" y="2296972"/>
+            <a:ext cx="1508760" cy="658368"/>
+          </a:xfrm>
+          <a:prstGeom prst="rect">
+            <a:avLst/>
+          </a:prstGeom>
+          <a:noFill/>
+        </p:spPr>
+        <p:txBody>
+          <a:bodyPr wrap="square" lIns="0" rIns="0" tIns="0" bIns="0" anchor="t">
+            <a:spAutoFit/>
+          </a:bodyPr>
+          <a:lstStyle/>
+          <a:p>
+            <a:pPr algn="l"/>
+            <a:r>
+              <a:rPr sz="1150" b="0" i="0">
+                <a:solidFill>
+                  <a:srgbClr val="1E293B"/>
+                </a:solidFill>
+                <a:latin typeface="Prompt"/>
+                <a:ea typeface="Prompt"/>
+                <a:cs typeface="Prompt"/>
+              </a:rPr>
+              <a:t>น้ำขังรอบบึงบอระเพ็ด ตรงกับที่ชาวบ้านเล่า</a:t>
+            </a:r>
+          </a:p>
+        </p:txBody>
+      </p:sp>
+      <p:sp>
+        <p:nvSpPr>
+          <p:cNvPr id="37" name="Rounded Rectangle 36"/>
+          <p:cNvSpPr/>
+          <p:nvPr/>
+        </p:nvSpPr>
+        <p:spPr>
+          <a:xfrm>
+            <a:off x="9765792" y="1481328"/>
+            <a:ext cx="1874519" cy="1463040"/>
+          </a:xfrm>
+          <a:prstGeom prst="roundRect">
+            <a:avLst>
+              <a:gd name="adj" fmla="val 6000"/>
+            </a:avLst>
+          </a:prstGeom>
+          <a:solidFill>
+            <a:srgbClr val="EEF5F9"/>
+          </a:solidFill>
+          <a:ln>
+            <a:noFill/>
+          </a:ln>
+          <a:effectLst/>
+        </p:spPr>
+        <p:style>
+          <a:lnRef idx="1">
+            <a:schemeClr val="accent1"/>
+          </a:lnRef>
+          <a:fillRef idx="3">
+            <a:schemeClr val="accent1"/>
+          </a:fillRef>
+          <a:effectRef idx="2">
+            <a:schemeClr val="accent1"/>
+          </a:effectRef>
+          <a:fontRef idx="minor">
+            <a:schemeClr val="lt1"/>
+          </a:fontRef>
+        </p:style>
+        <p:txBody>
+          <a:bodyPr rtlCol="0" anchor="ctr"/>
+          <a:lstStyle/>
+          <a:p/>
+        </p:txBody>
+      </p:sp>
+      <p:sp>
+        <p:nvSpPr>
+          <p:cNvPr id="38" name="TextBox 37"/>
+          <p:cNvSpPr txBox="1"/>
+          <p:nvPr/>
+        </p:nvSpPr>
+        <p:spPr>
+          <a:xfrm>
+            <a:off x="9966960" y="1609344"/>
+            <a:ext cx="1508760" cy="658368"/>
+          </a:xfrm>
+          <a:prstGeom prst="rect">
+            <a:avLst/>
+          </a:prstGeom>
+          <a:noFill/>
+        </p:spPr>
+        <p:txBody>
+          <a:bodyPr wrap="square" lIns="0" rIns="0" tIns="0" bIns="0" anchor="ctr">
+            <a:spAutoFit/>
+          </a:bodyPr>
+          <a:lstStyle/>
+          <a:p>
+            <a:pPr algn="l"/>
+            <a:r>
+              <a:rPr sz="2800" b="1" i="0">
+                <a:solidFill>
+                  <a:srgbClr val="1B998B"/>
+                </a:solidFill>
+                <a:latin typeface="Prompt"/>
+                <a:ea typeface="Prompt"/>
+                <a:cs typeface="Prompt"/>
+              </a:rPr>
+              <a:t>~0.5</a:t>
+            </a:r>
+            <a:r>
+              <a:rPr sz="1300" b="0" i="0">
+                <a:solidFill>
+                  <a:srgbClr val="64748B"/>
+                </a:solidFill>
+                <a:latin typeface="Prompt"/>
+                <a:ea typeface="Prompt"/>
+                <a:cs typeface="Prompt"/>
+              </a:rPr>
+              <a:t>  CSI</a:t>
+            </a:r>
+          </a:p>
+        </p:txBody>
+      </p:sp>
+      <p:sp>
+        <p:nvSpPr>
+          <p:cNvPr id="39" name="TextBox 38"/>
+          <p:cNvSpPr txBox="1"/>
+          <p:nvPr/>
+        </p:nvSpPr>
+        <p:spPr>
+          <a:xfrm>
+            <a:off x="9966960" y="2296972"/>
+            <a:ext cx="1508760" cy="658368"/>
+          </a:xfrm>
+          <a:prstGeom prst="rect">
+            <a:avLst/>
+          </a:prstGeom>
+          <a:noFill/>
+        </p:spPr>
+        <p:txBody>
+          <a:bodyPr wrap="square" lIns="0" rIns="0" tIns="0" bIns="0" anchor="t">
+            <a:spAutoFit/>
+          </a:bodyPr>
+          <a:lstStyle/>
+          <a:p>
+            <a:pPr algn="l"/>
+            <a:r>
+              <a:rPr sz="1150" b="0" i="0">
+                <a:solidFill>
+                  <a:srgbClr val="1E293B"/>
+                </a:solidFill>
+                <a:latin typeface="Prompt"/>
+                <a:ea typeface="Prompt"/>
+                <a:cs typeface="Prompt"/>
+              </a:rPr>
+              <a:t>ความแม่นยำเชิงพื้นที่ 3 เหตุการณ์</a:t>
+            </a:r>
+          </a:p>
+        </p:txBody>
+      </p:sp>
+      <p:sp>
+        <p:nvSpPr>
+          <p:cNvPr id="40" name="Rounded Rectangle 39"/>
+          <p:cNvSpPr/>
+          <p:nvPr/>
+        </p:nvSpPr>
+        <p:spPr>
+          <a:xfrm>
+            <a:off x="5760720" y="3108960"/>
+            <a:ext cx="5879592" cy="1600200"/>
+          </a:xfrm>
+          <a:prstGeom prst="roundRect">
+            <a:avLst>
+              <a:gd name="adj" fmla="val 6000"/>
+            </a:avLst>
+          </a:prstGeom>
+          <a:solidFill>
+            <a:srgbClr val="EEF5F9"/>
+          </a:solidFill>
+          <a:ln>
+            <a:noFill/>
+          </a:ln>
+          <a:effectLst/>
+        </p:spPr>
+        <p:style>
+          <a:lnRef idx="1">
+            <a:schemeClr val="accent1"/>
+          </a:lnRef>
+          <a:fillRef idx="3">
+            <a:schemeClr val="accent1"/>
+          </a:fillRef>
+          <a:effectRef idx="2">
+            <a:schemeClr val="accent1"/>
+          </a:effectRef>
+          <a:fontRef idx="minor">
+            <a:schemeClr val="lt1"/>
+          </a:fontRef>
+        </p:style>
+        <p:txBody>
+          <a:bodyPr rtlCol="0" anchor="ctr"/>
+          <a:lstStyle/>
+          <a:p/>
+        </p:txBody>
+      </p:sp>
+      <p:sp>
+        <p:nvSpPr>
+          <p:cNvPr id="41" name="TextBox 40"/>
+          <p:cNvSpPr txBox="1"/>
+          <p:nvPr/>
+        </p:nvSpPr>
+        <p:spPr>
+          <a:xfrm>
+            <a:off x="5961888" y="3218688"/>
+            <a:ext cx="5486400" cy="365760"/>
+          </a:xfrm>
+          <a:prstGeom prst="rect">
+            <a:avLst/>
+          </a:prstGeom>
+          <a:noFill/>
+        </p:spPr>
+        <p:txBody>
+          <a:bodyPr wrap="square" lIns="0" rIns="0" tIns="0" bIns="0" anchor="t">
+            <a:spAutoFit/>
+          </a:bodyPr>
+          <a:lstStyle/>
+          <a:p>
+            <a:pPr algn="l"/>
+            <a:r>
+              <a:rPr sz="1400" b="1" i="0">
+                <a:solidFill>
+                  <a:srgbClr val="0B3C5D"/>
+                </a:solidFill>
+                <a:latin typeface="Prompt"/>
+                <a:ea typeface="Prompt"/>
+                <a:cs typeface="Prompt"/>
+              </a:rPr>
+              <a:t>สิ่งที่ได้จากการวิเคราะห์</a:t>
+            </a:r>
+          </a:p>
+        </p:txBody>
+      </p:sp>
+      <p:sp>
+        <p:nvSpPr>
+          <p:cNvPr id="42" name="TextBox 41"/>
+          <p:cNvSpPr txBox="1"/>
+          <p:nvPr/>
+        </p:nvSpPr>
+        <p:spPr>
+          <a:xfrm>
+            <a:off x="5961888" y="3611880"/>
+            <a:ext cx="5486400" cy="1051560"/>
+          </a:xfrm>
+          <a:prstGeom prst="rect">
+            <a:avLst/>
+          </a:prstGeom>
+          <a:noFill/>
+        </p:spPr>
+        <p:txBody>
+          <a:bodyPr wrap="square" lIns="0" rIns="0" tIns="0" bIns="0" anchor="t">
+            <a:spAutoFit/>
+          </a:bodyPr>
+          <a:lstStyle/>
+          <a:p>
+            <a:pPr algn="l" marL="228600" indent="-228600">
+              <a:buFont typeface="Arial"/>
+              <a:buChar char="•"/>
+            </a:pPr>
+            <a:r>
+              <a:rPr sz="1200" b="0" i="0">
+                <a:solidFill>
+                  <a:srgbClr val="1E293B"/>
+                </a:solidFill>
+                <a:latin typeface="Prompt"/>
+                <a:ea typeface="Prompt"/>
+                <a:cs typeface="Prompt"/>
+              </a:rPr>
+              <a:t>พื้นที่ที่ท่วมซ้ำทุกปีน้ำมาก: ทับกฤช วังมหากร พนมเศษ พระนอน</a:t>
+            </a:r>
+          </a:p>
+          <a:p>
+            <a:pPr algn="l" marL="228600" indent="-228600">
+              <a:spcBef>
+                <a:spcPts val="300"/>
+              </a:spcBef>
+              <a:buFont typeface="Arial"/>
+              <a:buChar char="•"/>
+            </a:pPr>
+            <a:r>
+              <a:rPr sz="1200" b="0" i="0">
+                <a:solidFill>
+                  <a:srgbClr val="1E293B"/>
+                </a:solidFill>
+                <a:latin typeface="Prompt"/>
+                <a:ea typeface="Prompt"/>
+                <a:cs typeface="Prompt"/>
+              </a:rPr>
+              <a:t>จำลองพื้นที่ท่วมนานได้ใกล้ของจริง (ต่างไม่เกิน ~20%)</a:t>
+            </a:r>
+          </a:p>
+        </p:txBody>
+      </p:sp>
+      <p:sp>
+        <p:nvSpPr>
+          <p:cNvPr id="43" name="Rounded Rectangle 42"/>
+          <p:cNvSpPr/>
+          <p:nvPr/>
+        </p:nvSpPr>
+        <p:spPr>
+          <a:xfrm>
+            <a:off x="5760720" y="4846320"/>
+            <a:ext cx="5879592" cy="1417320"/>
+          </a:xfrm>
+          <a:prstGeom prst="roundRect">
+            <a:avLst>
+              <a:gd name="adj" fmla="val 6000"/>
+            </a:avLst>
+          </a:prstGeom>
+          <a:solidFill>
+            <a:srgbClr val="FFF4E5"/>
+          </a:solidFill>
+          <a:ln>
+            <a:noFill/>
+          </a:ln>
+          <a:effectLst/>
+        </p:spPr>
+        <p:style>
+          <a:lnRef idx="1">
+            <a:schemeClr val="accent1"/>
+          </a:lnRef>
+          <a:fillRef idx="3">
+            <a:schemeClr val="accent1"/>
+          </a:fillRef>
+          <a:effectRef idx="2">
+            <a:schemeClr val="accent1"/>
+          </a:effectRef>
+          <a:fontRef idx="minor">
+            <a:schemeClr val="lt1"/>
+          </a:fontRef>
+        </p:style>
+        <p:txBody>
+          <a:bodyPr rtlCol="0" anchor="ctr"/>
+          <a:lstStyle/>
+          <a:p/>
+        </p:txBody>
+      </p:sp>
+      <p:sp>
+        <p:nvSpPr>
+          <p:cNvPr id="44" name="TextBox 43"/>
+          <p:cNvSpPr txBox="1"/>
+          <p:nvPr/>
+        </p:nvSpPr>
+        <p:spPr>
+          <a:xfrm>
+            <a:off x="5961888" y="4937760"/>
+            <a:ext cx="5486400" cy="365760"/>
+          </a:xfrm>
+          <a:prstGeom prst="rect">
+            <a:avLst/>
+          </a:prstGeom>
+          <a:noFill/>
+        </p:spPr>
+        <p:txBody>
+          <a:bodyPr wrap="square" lIns="0" rIns="0" tIns="0" bIns="0" anchor="t">
+            <a:spAutoFit/>
+          </a:bodyPr>
+          <a:lstStyle/>
+          <a:p>
+            <a:pPr algn="l"/>
+            <a:r>
+              <a:rPr sz="1400" b="1" i="0">
+                <a:solidFill>
+                  <a:srgbClr val="0B3C5D"/>
+                </a:solidFill>
+                <a:latin typeface="Prompt"/>
+                <a:ea typeface="Prompt"/>
+                <a:cs typeface="Prompt"/>
+              </a:rPr>
+              <a:t>นัยต่อการบริหารน้ำ</a:t>
+            </a:r>
+          </a:p>
+        </p:txBody>
+      </p:sp>
+      <p:sp>
+        <p:nvSpPr>
+          <p:cNvPr id="45" name="TextBox 44"/>
+          <p:cNvSpPr txBox="1"/>
+          <p:nvPr/>
+        </p:nvSpPr>
+        <p:spPr>
+          <a:xfrm>
+            <a:off x="5961888" y="5321808"/>
+            <a:ext cx="5486400" cy="914400"/>
+          </a:xfrm>
+          <a:prstGeom prst="rect">
+            <a:avLst/>
+          </a:prstGeom>
+          <a:noFill/>
+        </p:spPr>
+        <p:txBody>
+          <a:bodyPr wrap="square" lIns="0" rIns="0" tIns="0" bIns="0" anchor="t">
+            <a:spAutoFit/>
+          </a:bodyPr>
+          <a:lstStyle/>
+          <a:p>
+            <a:pPr algn="l"/>
+            <a:r>
+              <a:rPr sz="1200" b="0" i="0">
+                <a:solidFill>
+                  <a:srgbClr val="1E293B"/>
+                </a:solidFill>
+                <a:latin typeface="Prompt"/>
+                <a:ea typeface="Prompt"/>
+                <a:cs typeface="Prompt"/>
+              </a:rPr>
+              <a:t>ท่วมนานเพราะน้ำจากแม่น้ำเข้าบึงผ่านคลองและประตูน้ำ ก่อนระดับน้ำถึงตลิ่ง → จัดการที่ประตูน้ำ/คลองตรงจุดได้ผลกว่าเฝ้าดูแค่ระดับตลิ่ง</a:t>
+            </a:r>
+          </a:p>
+        </p:txBody>
+      </p:sp>
+      <p:sp>
+        <p:nvSpPr>
+          <p:cNvPr id="46" name="TextBox 45"/>
+          <p:cNvSpPr txBox="1"/>
+          <p:nvPr/>
+        </p:nvSpPr>
+        <p:spPr>
+          <a:xfrm>
+            <a:off x="548640" y="6400800"/>
+            <a:ext cx="10332720" cy="274320"/>
+          </a:xfrm>
+          <a:prstGeom prst="rect">
+            <a:avLst/>
+          </a:prstGeom>
+          <a:noFill/>
+        </p:spPr>
+        <p:txBody>
+          <a:bodyPr wrap="square" lIns="0" rIns="0" tIns="0" bIns="0" anchor="t">
+            <a:spAutoFit/>
+          </a:bodyPr>
+          <a:lstStyle/>
+          <a:p>
+            <a:pPr algn="l"/>
+            <a:r>
+              <a:rPr sz="900" b="0" i="0">
+                <a:solidFill>
+                  <a:srgbClr val="64748B"/>
+                </a:solidFill>
+                <a:latin typeface="Prompt"/>
+                <a:ea typeface="Prompt"/>
+                <a:cs typeface="Prompt"/>
+              </a:rPr>
+              <a:t>Sentinel-1 (Copernicus) ผ่าน Microsoft Planetary Computer · ระดับน้ำจริง ThaiWater (สสน.) · ฝน ERA5 · CSI = พื้นที่ตรงกัน ÷ (ตรงกัน + ขาด + เกิน)</a:t>
+            </a:r>
+          </a:p>
+        </p:txBody>
+      </p:sp>
     </p:spTree>
   </p:cSld>
   <p:clrMapOvr>

</xml_diff>